<commit_message>
New project title: Handwritten Modi Character Recognition using Handcrafted Features
Title changed in the synopsis (docx and PDF), README heading, literature review deck and the web app footer. README headline numbers updated to the current results.
</commit_message>
<xml_diff>
--- a/docs/01_literature_survey/Literature_Review_Presentation.pptx
+++ b/docs/01_literature_survey/Literature_Review_Presentation.pptx
@@ -124,21 +124,21 @@
   <p:extLst>
     <p:ext uri="{521415D9-36F7-43E2-AB2F-B90AF26B5E84}">
       <p14:sectionLst xmlns:p14="http://schemas.microsoft.com/office/powerpoint/2010/main">
-        <p14:section name="Introduction" id="{0f70bf9b-16fa-e0f9-7ad0-2879c9de8702}">
+        <p14:section name="Introduction" id="{3fc1688b-1faa-4720-fe55-61d4d6e7cdd9}">
           <p14:sldIdLst>
             <p14:sldId id="256"/>
             <p14:sldId id="257"/>
             <p14:sldId id="258"/>
           </p14:sldIdLst>
         </p14:section>
-        <p14:section name="All 30 papers" id="{70dd98b9-1677-6089-5b00-eeeb87bf3037}">
+        <p14:section name="All 30 papers" id="{9609ae0d-b610-f401-556b-d645ddf3f1e8}">
           <p14:sldIdLst>
             <p14:sldId id="259"/>
             <p14:sldId id="260"/>
             <p14:sldId id="261"/>
           </p14:sldIdLst>
         </p14:section>
-        <p14:section name="Base papers" id="{44f3d136-a4db-aada-272c-a3fa8eea78f1}">
+        <p14:section name="Base papers" id="{5c4d15e6-5f01-15eb-cf8f-6f1a051a5260}">
           <p14:sldIdLst>
             <p14:sldId id="262"/>
             <p14:sldId id="263"/>
@@ -150,7 +150,7 @@
             <p14:sldId id="269"/>
           </p14:sldIdLst>
         </p14:section>
-        <p14:section name="Findings and objectives" id="{9f0ebeeb-5c7c-12df-6db3-17b9c6f18a67}">
+        <p14:section name="Findings and objectives" id="{385aed5f-ff25-3ed8-1cde-edd0dd32ced5}">
           <p14:sldIdLst>
             <p14:sldId id="270"/>
             <p14:sldId id="271"/>
@@ -3377,8 +3377,8 @@
         </p:nvSpPr>
         <p:spPr>
           <a:xfrm>
-            <a:off x="731520" y="1371600"/>
-            <a:ext cx="10698480" cy="914400"/>
+            <a:off x="731520" y="1280160"/>
+            <a:ext cx="10698480" cy="1143000"/>
           </a:xfrm>
           <a:prstGeom prst="rect">
             <a:avLst/>
@@ -3394,7 +3394,7 @@
               <a:buNone/>
             </a:pPr>
             <a:r>
-              <a:rPr lang="en-US" sz="4000" b="1" dirty="0">
+              <a:rPr lang="en-US" sz="3400" b="1" dirty="0">
                 <a:solidFill>
                   <a:schemeClr val="bg1"/>
                 </a:solidFill>
@@ -3402,9 +3402,9 @@
                 <a:ea typeface="Cambria" pitchFamily="34" charset="-122"/>
                 <a:cs typeface="Cambria" pitchFamily="34" charset="-120"/>
               </a:rPr>
-              <a:t>Handwritten Modi Character Recognition</a:t>
+              <a:t>Handwritten Modi Character Recognition using Handcrafted Features</a:t>
             </a:r>
-            <a:endParaRPr lang="en-US" sz="4000" dirty="0"/>
+            <a:endParaRPr lang="en-US" sz="3400" dirty="0"/>
           </a:p>
         </p:txBody>
       </p:sp>
@@ -3416,7 +3416,7 @@
         </p:nvSpPr>
         <p:spPr>
           <a:xfrm>
-            <a:off x="731520" y="2286000"/>
+            <a:off x="731520" y="2514600"/>
             <a:ext cx="10698480" cy="457200"/>
           </a:xfrm>
           <a:prstGeom prst="rect">
@@ -3460,7 +3460,7 @@
         </p:blipFill>
         <p:spPr>
           <a:xfrm>
-            <a:off x="731520" y="3154680"/>
+            <a:off x="731520" y="3383280"/>
             <a:ext cx="10698480" cy="1335024"/>
           </a:xfrm>
           <a:prstGeom prst="rect">

</xml_diff>